<commit_message>
feat(ml): grid-search pass 2 + talking points + q0/q1/q2 labels
Pass-1 RF/XGB grids landed on boundary values; re-ran a focused 45+60-fit
probe centered on those winners with extended edges. All new winners are
interior — first-pass RMSEs were real floors, not grid artifacts. XGB q0
RMSE halved from 0.007 → 0.004 dec (R² 0.99998); q1 improved marginally
(0.053 → 0.048); q2 essentially unchanged (label noise floor).

- notebook.py: expanded is_big grids for reproducibility
- retune_eval.py: standalone pass-2 probe + figure regeneration
- retune_metrics.json: evidence of the tuning run
- build_presentation.js: slide 9 grid tables + pass-2 CV protocol note;
  slide 10 metric table refresh; slide 14 takeaway upgrade
- talking_points.md: 15-slide walk-through + Q&A prep
- PPT rename: q_wpm/q_wfm/q_rwfm → q0/q1/q2 in deck text only
  (source-code names unchanged per user)
- .gitignore: add retune.log

Co-Authored-By: Claude Opus 4.7 (1M context) <noreply@anthropic.com>
</commit_message>
<xml_diff>
--- a/ml/presentation.pptx
+++ b/ml/presentation.pptx
@@ -2843,7 +2843,7 @@
                           <a:ea typeface="Calibri" pitchFamily="34" charset="-122"/>
                           <a:cs typeface="Calibri" pitchFamily="34" charset="-120"/>
                         </a:rPr>
-                        <a:t>q_wpm</a:t>
+                        <a:t>q0</a:t>
                       </a:r>
                       <a:endParaRPr lang="en-US" sz="1000" dirty="0">
                         <a:latin typeface="Calibri" charset="0"/>
@@ -3170,7 +3170,7 @@
                           <a:ea typeface="Calibri" pitchFamily="34" charset="-122"/>
                           <a:cs typeface="Calibri" pitchFamily="34" charset="-120"/>
                         </a:rPr>
-                        <a:t>q_wpm</a:t>
+                        <a:t>q0</a:t>
                       </a:r>
                       <a:endParaRPr lang="en-US" sz="1000" dirty="0">
                         <a:latin typeface="Calibri" charset="0"/>
@@ -3300,7 +3300,7 @@
                           <a:ea typeface="Calibri" pitchFamily="34" charset="-122"/>
                           <a:cs typeface="Calibri" pitchFamily="34" charset="-120"/>
                         </a:rPr>
-                        <a:t>0.069</a:t>
+                        <a:t>0.047</a:t>
                       </a:r>
                       <a:endParaRPr lang="en-US" sz="1000" dirty="0">
                         <a:latin typeface="Calibri" charset="0"/>
@@ -3365,7 +3365,7 @@
                           <a:ea typeface="Calibri" pitchFamily="34" charset="-122"/>
                           <a:cs typeface="Calibri" pitchFamily="34" charset="-120"/>
                         </a:rPr>
-                        <a:t>0.994</a:t>
+                        <a:t>0.997</a:t>
                       </a:r>
                       <a:endParaRPr lang="en-US" sz="1000" dirty="0">
                         <a:latin typeface="Calibri" charset="0"/>
@@ -3430,7 +3430,7 @@
                           <a:ea typeface="Calibri" pitchFamily="34" charset="-122"/>
                           <a:cs typeface="Calibri" pitchFamily="34" charset="-120"/>
                         </a:rPr>
-                        <a:t>0.052</a:t>
+                        <a:t>0.034</a:t>
                       </a:r>
                       <a:endParaRPr lang="en-US" sz="1000" dirty="0">
                         <a:latin typeface="Calibri" charset="0"/>
@@ -3497,7 +3497,7 @@
                           <a:ea typeface="Calibri" pitchFamily="34" charset="-122"/>
                           <a:cs typeface="Calibri" pitchFamily="34" charset="-120"/>
                         </a:rPr>
-                        <a:t>q_wpm</a:t>
+                        <a:t>q0</a:t>
                       </a:r>
                       <a:endParaRPr lang="en-US" sz="1000" dirty="0">
                         <a:latin typeface="Calibri" charset="0"/>
@@ -3627,7 +3627,7 @@
                           <a:ea typeface="Calibri" pitchFamily="34" charset="-122"/>
                           <a:cs typeface="Calibri" pitchFamily="34" charset="-120"/>
                         </a:rPr>
-                        <a:t>0.007</a:t>
+                        <a:t>0.004</a:t>
                       </a:r>
                       <a:endParaRPr lang="en-US" sz="1000" dirty="0">
                         <a:latin typeface="Calibri" charset="0"/>
@@ -3692,7 +3692,7 @@
                           <a:ea typeface="Calibri" pitchFamily="34" charset="-122"/>
                           <a:cs typeface="Calibri" pitchFamily="34" charset="-120"/>
                         </a:rPr>
-                        <a:t>0.99993</a:t>
+                        <a:t>0.99998</a:t>
                       </a:r>
                       <a:endParaRPr lang="en-US" sz="1000" dirty="0">
                         <a:latin typeface="Calibri" charset="0"/>
@@ -3757,7 +3757,7 @@
                           <a:ea typeface="Calibri" pitchFamily="34" charset="-122"/>
                           <a:cs typeface="Calibri" pitchFamily="34" charset="-120"/>
                         </a:rPr>
-                        <a:t>0.006</a:t>
+                        <a:t>0.003</a:t>
                       </a:r>
                       <a:endParaRPr lang="en-US" sz="1000" dirty="0">
                         <a:latin typeface="Calibri" charset="0"/>
@@ -3824,7 +3824,7 @@
                           <a:ea typeface="Calibri" pitchFamily="34" charset="-122"/>
                           <a:cs typeface="Calibri" pitchFamily="34" charset="-120"/>
                         </a:rPr>
-                        <a:t>q_wfm</a:t>
+                        <a:t>q1</a:t>
                       </a:r>
                       <a:endParaRPr lang="en-US" sz="1000" dirty="0">
                         <a:latin typeface="Calibri" charset="0"/>
@@ -4151,7 +4151,7 @@
                           <a:ea typeface="Calibri" pitchFamily="34" charset="-122"/>
                           <a:cs typeface="Calibri" pitchFamily="34" charset="-120"/>
                         </a:rPr>
-                        <a:t>q_wfm</a:t>
+                        <a:t>q1</a:t>
                       </a:r>
                       <a:endParaRPr lang="en-US" sz="1000" dirty="0">
                         <a:latin typeface="Calibri" charset="0"/>
@@ -4281,7 +4281,7 @@
                           <a:ea typeface="Calibri" pitchFamily="34" charset="-122"/>
                           <a:cs typeface="Calibri" pitchFamily="34" charset="-120"/>
                         </a:rPr>
-                        <a:t>0.090</a:t>
+                        <a:t>0.080</a:t>
                       </a:r>
                       <a:endParaRPr lang="en-US" sz="1000" dirty="0">
                         <a:latin typeface="Calibri" charset="0"/>
@@ -4346,7 +4346,7 @@
                           <a:ea typeface="Calibri" pitchFamily="34" charset="-122"/>
                           <a:cs typeface="Calibri" pitchFamily="34" charset="-120"/>
                         </a:rPr>
-                        <a:t>0.989</a:t>
+                        <a:t>0.992</a:t>
                       </a:r>
                       <a:endParaRPr lang="en-US" sz="1000" dirty="0">
                         <a:latin typeface="Calibri" charset="0"/>
@@ -4411,7 +4411,7 @@
                           <a:ea typeface="Calibri" pitchFamily="34" charset="-122"/>
                           <a:cs typeface="Calibri" pitchFamily="34" charset="-120"/>
                         </a:rPr>
-                        <a:t>0.065</a:t>
+                        <a:t>0.055</a:t>
                       </a:r>
                       <a:endParaRPr lang="en-US" sz="1000" dirty="0">
                         <a:latin typeface="Calibri" charset="0"/>
@@ -4478,7 +4478,7 @@
                           <a:ea typeface="Calibri" pitchFamily="34" charset="-122"/>
                           <a:cs typeface="Calibri" pitchFamily="34" charset="-120"/>
                         </a:rPr>
-                        <a:t>q_wfm</a:t>
+                        <a:t>q1</a:t>
                       </a:r>
                       <a:endParaRPr lang="en-US" sz="1000" dirty="0">
                         <a:latin typeface="Calibri" charset="0"/>
@@ -4608,7 +4608,7 @@
                           <a:ea typeface="Calibri" pitchFamily="34" charset="-122"/>
                           <a:cs typeface="Calibri" pitchFamily="34" charset="-120"/>
                         </a:rPr>
-                        <a:t>0.053</a:t>
+                        <a:t>0.048</a:t>
                       </a:r>
                       <a:endParaRPr lang="en-US" sz="1000" dirty="0">
                         <a:latin typeface="Calibri" charset="0"/>
@@ -4673,7 +4673,7 @@
                           <a:ea typeface="Calibri" pitchFamily="34" charset="-122"/>
                           <a:cs typeface="Calibri" pitchFamily="34" charset="-120"/>
                         </a:rPr>
-                        <a:t>0.996</a:t>
+                        <a:t>0.997</a:t>
                       </a:r>
                       <a:endParaRPr lang="en-US" sz="1000" dirty="0">
                         <a:latin typeface="Calibri" charset="0"/>
@@ -4738,7 +4738,7 @@
                           <a:ea typeface="Calibri" pitchFamily="34" charset="-122"/>
                           <a:cs typeface="Calibri" pitchFamily="34" charset="-120"/>
                         </a:rPr>
-                        <a:t>0.030</a:t>
+                        <a:t>0.027</a:t>
                       </a:r>
                       <a:endParaRPr lang="en-US" sz="1000" dirty="0">
                         <a:latin typeface="Calibri" charset="0"/>
@@ -4805,7 +4805,7 @@
                           <a:ea typeface="Calibri" pitchFamily="34" charset="-122"/>
                           <a:cs typeface="Calibri" pitchFamily="34" charset="-120"/>
                         </a:rPr>
-                        <a:t>q_rwfm</a:t>
+                        <a:t>q2</a:t>
                       </a:r>
                       <a:endParaRPr lang="en-US" sz="1000" dirty="0">
                         <a:latin typeface="Calibri" charset="0"/>
@@ -5132,7 +5132,7 @@
                           <a:ea typeface="Calibri" pitchFamily="34" charset="-122"/>
                           <a:cs typeface="Calibri" pitchFamily="34" charset="-120"/>
                         </a:rPr>
-                        <a:t>q_rwfm</a:t>
+                        <a:t>q2</a:t>
                       </a:r>
                       <a:endParaRPr lang="en-US" sz="1000" dirty="0">
                         <a:latin typeface="Calibri" charset="0"/>
@@ -5262,7 +5262,7 @@
                           <a:ea typeface="Calibri" pitchFamily="34" charset="-122"/>
                           <a:cs typeface="Calibri" pitchFamily="34" charset="-120"/>
                         </a:rPr>
-                        <a:t>0.784</a:t>
+                        <a:t>0.786</a:t>
                       </a:r>
                       <a:endParaRPr lang="en-US" sz="1000" dirty="0">
                         <a:latin typeface="Calibri" charset="0"/>
@@ -5327,7 +5327,7 @@
                           <a:ea typeface="Calibri" pitchFamily="34" charset="-122"/>
                           <a:cs typeface="Calibri" pitchFamily="34" charset="-120"/>
                         </a:rPr>
-                        <a:t>0.795</a:t>
+                        <a:t>0.794</a:t>
                       </a:r>
                       <a:endParaRPr lang="en-US" sz="1000" dirty="0">
                         <a:latin typeface="Calibri" charset="0"/>
@@ -5392,7 +5392,7 @@
                           <a:ea typeface="Calibri" pitchFamily="34" charset="-122"/>
                           <a:cs typeface="Calibri" pitchFamily="34" charset="-120"/>
                         </a:rPr>
-                        <a:t>0.551</a:t>
+                        <a:t>0.552</a:t>
                       </a:r>
                       <a:endParaRPr lang="en-US" sz="1000" dirty="0">
                         <a:latin typeface="Calibri" charset="0"/>
@@ -5459,7 +5459,7 @@
                           <a:ea typeface="Calibri" pitchFamily="34" charset="-122"/>
                           <a:cs typeface="Calibri" pitchFamily="34" charset="-120"/>
                         </a:rPr>
-                        <a:t>q_rwfm</a:t>
+                        <a:t>q2</a:t>
                       </a:r>
                       <a:endParaRPr lang="en-US" sz="1000" dirty="0">
                         <a:latin typeface="Calibri" charset="0"/>
@@ -5589,7 +5589,7 @@
                           <a:ea typeface="Calibri" pitchFamily="34" charset="-122"/>
                           <a:cs typeface="Calibri" pitchFamily="34" charset="-120"/>
                         </a:rPr>
-                        <a:t>0.736</a:t>
+                        <a:t>0.733</a:t>
                       </a:r>
                       <a:endParaRPr lang="en-US" sz="1000" dirty="0">
                         <a:latin typeface="Calibri" charset="0"/>
@@ -5654,7 +5654,7 @@
                           <a:ea typeface="Calibri" pitchFamily="34" charset="-122"/>
                           <a:cs typeface="Calibri" pitchFamily="34" charset="-120"/>
                         </a:rPr>
-                        <a:t>0.819</a:t>
+                        <a:t>0.821</a:t>
                       </a:r>
                       <a:endParaRPr lang="en-US" sz="1000" dirty="0">
                         <a:latin typeface="Calibri" charset="0"/>
@@ -5719,7 +5719,7 @@
                           <a:ea typeface="Calibri" pitchFamily="34" charset="-122"/>
                           <a:cs typeface="Calibri" pitchFamily="34" charset="-120"/>
                         </a:rPr>
-                        <a:t>0.510</a:t>
+                        <a:t>0.506</a:t>
                       </a:r>
                       <a:endParaRPr lang="en-US" sz="1000" dirty="0">
                         <a:latin typeface="Calibri" charset="0"/>
@@ -5868,7 +5868,7 @@
                 <a:ea typeface="Calibri" pitchFamily="34" charset="-122"/>
                 <a:cs typeface="Calibri" pitchFamily="34" charset="-120"/>
               </a:rPr>
-              <a:t>XGB → &lt;0.05-dec RMSE on q_wpm &amp; q_wfm (R² ≥ 0.996); </a:t>
+              <a:t>XGB → &lt;0.05-dec RMSE on q0 &amp; q1 (R² ≥ 0.997); </a:t>
             </a:r>
             <a:pPr indent="0" marL="0">
               <a:buNone/>
@@ -5882,7 +5882,7 @@
                 <a:ea typeface="Calibri" pitchFamily="34" charset="-122"/>
                 <a:cs typeface="Calibri" pitchFamily="34" charset="-120"/>
               </a:rPr>
-              <a:t>q_rwfm R² = 0.82 </a:t>
+              <a:t>q2 R² = 0.82 </a:t>
             </a:r>
             <a:pPr indent="0" marL="0">
               <a:buNone/>
@@ -6359,7 +6359,7 @@
                 <a:ea typeface="Calibri" pitchFamily="34" charset="-122"/>
                 <a:cs typeface="Calibri" pitchFamily="34" charset="-120"/>
               </a:rPr>
-              <a:t>q_wpm 84%   q_wfm 81%   q_rwfm 81%</a:t>
+              <a:t>q0 84%   q1 81%   q2 81%</a:t>
             </a:r>
             <a:endParaRPr lang="en-US" sz="1100" dirty="0"/>
           </a:p>
@@ -7403,7 +7403,7 @@
                 <a:ea typeface="Calibri" pitchFamily="34" charset="-122"/>
                 <a:cs typeface="Calibri" pitchFamily="34" charset="-120"/>
               </a:rPr>
-              <a:t>ALS labels → noise-free targets (key finding; lifted q_rwfm R² from 0.65 → 0.82)</a:t>
+              <a:t>ALS labels → noise-free targets (key finding; lifted q2 R² from 0.65 → 0.82)</a:t>
             </a:r>
             <a:endParaRPr lang="en-US" sz="1000" dirty="0"/>
           </a:p>
@@ -7424,7 +7424,7 @@
                 <a:ea typeface="Calibri" pitchFamily="34" charset="-122"/>
                 <a:cs typeface="Calibri" pitchFamily="34" charset="-120"/>
               </a:rPr>
-              <a:t>XGB → sub-0.05-dec RMSE on q_wpm &amp; q_wfm</a:t>
+              <a:t>XGB → 0.004-dec RMSE on q0 (R² = 0.99998); &lt;0.05-dec on q1</a:t>
             </a:r>
             <a:endParaRPr lang="en-US" sz="1000" dirty="0"/>
           </a:p>
@@ -8756,7 +8756,7 @@
                 <a:ea typeface="Calibri" pitchFamily="34" charset="-122"/>
                 <a:cs typeface="Calibri" pitchFamily="34" charset="-120"/>
               </a:rPr>
-              <a:t>Targets: log₁₀(q_wpm), log₁₀(q_wfm), log₁₀(q_rwfm)</a:t>
+              <a:t>Targets: log₁₀(q0), log₁₀(q1), log₁₀(q2)</a:t>
             </a:r>
             <a:endParaRPr lang="en-US" sz="1200" dirty="0"/>
           </a:p>
@@ -12501,7 +12501,7 @@
                 <a:ea typeface="Calibri" pitchFamily="34" charset="-122"/>
                 <a:cs typeface="Calibri" pitchFamily="34" charset="-120"/>
               </a:rPr>
-              <a:t>Targets span ~6 log decades (q_rwfm widest; q_wpm tightest)</a:t>
+              <a:t>Targets span ~6 log decades (q2 widest; q0 tightest)</a:t>
             </a:r>
             <a:endParaRPr lang="en-US" sz="1000" dirty="0"/>
           </a:p>
@@ -12522,7 +12522,7 @@
                 <a:ea typeface="Calibri" pitchFamily="34" charset="-122"/>
                 <a:cs typeface="Calibri" pitchFamily="34" charset="-120"/>
               </a:rPr>
-              <a:t>Short-τ features (top row) correlate strongest with q_wpm</a:t>
+              <a:t>Short-τ features (top row) correlate strongest with q0</a:t>
             </a:r>
             <a:endParaRPr lang="en-US" sz="1000" dirty="0"/>
           </a:p>
@@ -12543,7 +12543,7 @@
                 <a:ea typeface="Calibri" pitchFamily="34" charset="-122"/>
                 <a:cs typeface="Calibri" pitchFamily="34" charset="-120"/>
               </a:rPr>
-              <a:t>Long-τ features correlate with q_rwfm (log₁₀ q ~ −30)</a:t>
+              <a:t>Long-τ features correlate with q2 (log₁₀ q ~ −30)</a:t>
             </a:r>
             <a:endParaRPr lang="en-US" sz="1000" dirty="0"/>
           </a:p>
@@ -13923,7 +13923,7 @@
                 <a:ea typeface="Calibri" pitchFamily="34" charset="-122"/>
                 <a:cs typeface="Calibri" pitchFamily="34" charset="-120"/>
               </a:rPr>
-              <a:t>short-τ features drive q_wpm; long-τ features drive q_rwfm. </a:t>
+              <a:t>short-τ features drive q0; long-τ features drive q2. </a:t>
             </a:r>
             <a:pPr indent="0" marL="0">
               <a:buNone/>
@@ -14781,7 +14781,7 @@
                 <a:ea typeface="Calibri" pitchFamily="34" charset="-122"/>
                 <a:cs typeface="Calibri" pitchFamily="34" charset="-120"/>
               </a:rPr>
-              <a:t>5-fold GridSearchCV with explicit justification per parameter.</a:t>
+              <a:t>Two-pass 5-fold GridSearchCV: expand, then re-center around boundary winners.</a:t>
             </a:r>
             <a:endParaRPr lang="en-US" sz="1300" dirty="0"/>
           </a:p>
@@ -15142,7 +15142,7 @@
                           <a:ea typeface="Calibri" pitchFamily="34" charset="-122"/>
                           <a:cs typeface="Calibri" pitchFamily="34" charset="-120"/>
                         </a:rPr>
-                        <a:t>{200, 500, 1000}</a:t>
+                        <a:t>{1000, 1500, 2000}</a:t>
                       </a:r>
                       <a:endParaRPr lang="en-US" sz="1000" dirty="0">
                         <a:latin typeface="Calibri" charset="0"/>
@@ -15339,7 +15339,7 @@
                           <a:ea typeface="Calibri" pitchFamily="34" charset="-122"/>
                           <a:cs typeface="Calibri" pitchFamily="34" charset="-120"/>
                         </a:rPr>
-                        <a:t>{None, 20, 30}</a:t>
+                        <a:t>{20}</a:t>
                       </a:r>
                       <a:endParaRPr lang="en-US" sz="1000" dirty="0">
                         <a:latin typeface="Calibri" charset="0"/>
@@ -15536,7 +15536,7 @@
                           <a:ea typeface="Calibri" pitchFamily="34" charset="-122"/>
                           <a:cs typeface="Calibri" pitchFamily="34" charset="-120"/>
                         </a:rPr>
-                        <a:t>{3, 5, 10}</a:t>
+                        <a:t>{1, 2, 3}</a:t>
                       </a:r>
                       <a:endParaRPr lang="en-US" sz="1000" dirty="0">
                         <a:latin typeface="Calibri" charset="0"/>
@@ -15601,7 +15601,7 @@
                           <a:ea typeface="Calibri" pitchFamily="34" charset="-122"/>
                           <a:cs typeface="Calibri" pitchFamily="34" charset="-120"/>
                         </a:rPr>
-                        <a:t>3</a:t>
+                        <a:t>1</a:t>
                       </a:r>
                       <a:endParaRPr lang="en-US" sz="1000" dirty="0">
                         <a:latin typeface="Calibri" charset="0"/>
@@ -15733,7 +15733,7 @@
                           <a:ea typeface="Calibri" pitchFamily="34" charset="-122"/>
                           <a:cs typeface="Calibri" pitchFamily="34" charset="-120"/>
                         </a:rPr>
-                        <a:t>{sqrt, 0.5}</a:t>
+                        <a:t>{0.5}</a:t>
                       </a:r>
                       <a:endParaRPr lang="en-US" sz="1000" dirty="0">
                         <a:latin typeface="Calibri" charset="0"/>
@@ -16206,7 +16206,7 @@
                           <a:ea typeface="Calibri" pitchFamily="34" charset="-122"/>
                           <a:cs typeface="Calibri" pitchFamily="34" charset="-120"/>
                         </a:rPr>
-                        <a:t>{200, 500}</a:t>
+                        <a:t>{500, 750, 1000}</a:t>
                       </a:r>
                       <a:endParaRPr lang="en-US" sz="1000" dirty="0">
                         <a:latin typeface="Calibri" charset="0"/>
@@ -16271,7 +16271,7 @@
                           <a:ea typeface="Calibri" pitchFamily="34" charset="-122"/>
                           <a:cs typeface="Calibri" pitchFamily="34" charset="-120"/>
                         </a:rPr>
-                        <a:t>500</a:t>
+                        <a:t>750</a:t>
                       </a:r>
                       <a:endParaRPr lang="en-US" sz="1000" dirty="0">
                         <a:latin typeface="Calibri" charset="0"/>
@@ -16403,7 +16403,7 @@
                           <a:ea typeface="Calibri" pitchFamily="34" charset="-122"/>
                           <a:cs typeface="Calibri" pitchFamily="34" charset="-120"/>
                         </a:rPr>
-                        <a:t>{0.01, 0.05, 0.1}</a:t>
+                        <a:t>{0.003, 0.01}</a:t>
                       </a:r>
                       <a:endParaRPr lang="en-US" sz="1000" dirty="0">
                         <a:latin typeface="Calibri" charset="0"/>
@@ -16600,7 +16600,7 @@
                           <a:ea typeface="Calibri" pitchFamily="34" charset="-122"/>
                           <a:cs typeface="Calibri" pitchFamily="34" charset="-120"/>
                         </a:rPr>
-                        <a:t>{4, 6, 8}</a:t>
+                        <a:t>{6}</a:t>
                       </a:r>
                       <a:endParaRPr lang="en-US" sz="1000" dirty="0">
                         <a:latin typeface="Calibri" charset="0"/>
@@ -16797,7 +16797,7 @@
                           <a:ea typeface="Calibri" pitchFamily="34" charset="-122"/>
                           <a:cs typeface="Calibri" pitchFamily="34" charset="-120"/>
                         </a:rPr>
-                        <a:t>{0.8, 1.0}</a:t>
+                        <a:t>{0.7, 0.8}</a:t>
                       </a:r>
                       <a:endParaRPr lang="en-US" sz="1000" dirty="0">
                         <a:latin typeface="Calibri" charset="0"/>
@@ -16862,7 +16862,7 @@
                           <a:ea typeface="Calibri" pitchFamily="34" charset="-122"/>
                           <a:cs typeface="Calibri" pitchFamily="34" charset="-120"/>
                         </a:rPr>
-                        <a:t>0.8</a:t>
+                        <a:t>0.7</a:t>
                       </a:r>
                       <a:endParaRPr lang="en-US" sz="1000" dirty="0">
                         <a:latin typeface="Calibri" charset="0"/>
@@ -17012,13 +17012,13 @@
                 <a:ea typeface="Calibri" pitchFamily="34" charset="-122"/>
                 <a:cs typeface="Calibri" pitchFamily="34" charset="-120"/>
               </a:rPr>
-              <a:t>5-fold CV  •  270 RF fits + 180 XGB fits  •  </a:t>
+              <a:t>5-fold CV  •  Pass 1 landed on boundaries (n_est top, lr bottom, subsample bottom)  •  </a:t>
             </a:r>
             <a:pPr indent="0" marL="0">
               <a:buNone/>
             </a:pPr>
             <a:r>
-              <a:rPr lang="en-US" sz="1100" dirty="0">
+              <a:rPr lang="en-US" sz="1100" b="1" dirty="0">
                 <a:solidFill>
                   <a:srgbClr val="1A1A2E"/>
                 </a:solidFill>
@@ -17026,13 +17026,13 @@
                 <a:ea typeface="Calibri" pitchFamily="34" charset="-122"/>
                 <a:cs typeface="Calibri" pitchFamily="34" charset="-120"/>
               </a:rPr>
-              <a:t>scoring = </a:t>
+              <a:t>Pass 2 probe</a:t>
             </a:r>
             <a:pPr indent="0" marL="0">
               <a:buNone/>
             </a:pPr>
             <a:r>
-              <a:rPr lang="en-US" sz="1100" b="1" dirty="0">
+              <a:rPr lang="en-US" sz="1100" dirty="0">
                 <a:solidFill>
                   <a:srgbClr val="1A1A2E"/>
                 </a:solidFill>
@@ -17040,13 +17040,13 @@
                 <a:ea typeface="Calibri" pitchFamily="34" charset="-122"/>
                 <a:cs typeface="Calibri" pitchFamily="34" charset="-120"/>
               </a:rPr>
-              <a:t>neg_mean_squared_error</a:t>
+              <a:t> = 45 RF + 60 XGB fits centered on pass-1 winners, extending past boundaries  →  </a:t>
             </a:r>
             <a:pPr indent="0" marL="0">
               <a:buNone/>
             </a:pPr>
             <a:r>
-              <a:rPr lang="en-US" sz="1100" dirty="0">
+              <a:rPr lang="en-US" sz="1100" b="1" dirty="0">
                 <a:solidFill>
                   <a:srgbClr val="1A1A2E"/>
                 </a:solidFill>
@@ -17054,7 +17054,7 @@
                 <a:ea typeface="Calibri" pitchFamily="34" charset="-122"/>
                 <a:cs typeface="Calibri" pitchFamily="34" charset="-120"/>
               </a:rPr>
-              <a:t> in log₁₀-q space  •  </a:t>
+              <a:t>new winners are interior</a:t>
             </a:r>
             <a:pPr indent="0" marL="0">
               <a:buNone/>
@@ -17068,7 +17068,7 @@
                 <a:ea typeface="Calibri" pitchFamily="34" charset="-122"/>
                 <a:cs typeface="Calibri" pitchFamily="34" charset="-120"/>
               </a:rPr>
-              <a:t>seed = 42 for reproducibility</a:t>
+              <a:t>; scoring = neg-MSE in log₁₀-q; seed = 42.</a:t>
             </a:r>
             <a:endParaRPr lang="en-US" sz="1100" dirty="0"/>
           </a:p>

</xml_diff>

<commit_message>
fix(ml/presentation): drop unreferenced linear-regression baseline
Slide 7 baseline table listed "Linear regression (not run)" as a
placeholder; removed the row and updated the RF-vs-naive deltas to the
pass-2 numbers (~18×/11×/2× on q0/q1/q2). talking_points.md updated to
match.

Co-Authored-By: Claude Opus 4.7 (1M context) <noreply@anthropic.com>
</commit_message>
<xml_diff>
--- a/ml/presentation.pptx
+++ b/ml/presentation.pptx
@@ -13266,203 +13266,6 @@
                           <a:ea typeface="Calibri" pitchFamily="34" charset="-122"/>
                           <a:cs typeface="Calibri" pitchFamily="34" charset="-120"/>
                         </a:rPr>
-                        <a:t>Linear regression</a:t>
-                      </a:r>
-                      <a:endParaRPr lang="en-US" sz="1000" dirty="0">
-                        <a:latin typeface="Calibri" charset="0"/>
-                        <a:ea typeface="Calibri" charset="0"/>
-                        <a:cs typeface="Calibri" charset="0"/>
-                      </a:endParaRPr>
-                    </a:p>
-                  </a:txBody>
-                  <a:tcPr marL="91440" marR="91440" marT="45720" marB="45720">
-                    <a:lnL w="6350" cap="flat" cmpd="sng" algn="ctr">
-                      <a:solidFill>
-                        <a:srgbClr val="CCCCCC"/>
-                      </a:solidFill>
-                      <a:prstDash val="solid"/>
-                      <a:round/>
-                      <a:headEnd type="none" w="med" len="med"/>
-                      <a:tailEnd type="none" w="med" len="med"/>
-                    </a:lnL>
-                    <a:lnR w="6350" cap="flat" cmpd="sng" algn="ctr">
-                      <a:solidFill>
-                        <a:srgbClr val="CCCCCC"/>
-                      </a:solidFill>
-                      <a:prstDash val="solid"/>
-                      <a:round/>
-                      <a:headEnd type="none" w="med" len="med"/>
-                      <a:tailEnd type="none" w="med" len="med"/>
-                    </a:lnR>
-                    <a:lnT w="6350" cap="flat" cmpd="sng" algn="ctr">
-                      <a:solidFill>
-                        <a:srgbClr val="CCCCCC"/>
-                      </a:solidFill>
-                      <a:prstDash val="solid"/>
-                      <a:round/>
-                      <a:headEnd type="none" w="med" len="med"/>
-                      <a:tailEnd type="none" w="med" len="med"/>
-                    </a:lnT>
-                    <a:lnB w="6350" cap="flat" cmpd="sng" algn="ctr">
-                      <a:solidFill>
-                        <a:srgbClr val="CCCCCC"/>
-                      </a:solidFill>
-                      <a:prstDash val="solid"/>
-                      <a:round/>
-                      <a:headEnd type="none" w="med" len="med"/>
-                      <a:tailEnd type="none" w="med" len="med"/>
-                    </a:lnB>
-                  </a:tcPr>
-                </a:tc>
-                <a:tc>
-                  <a:txBody>
-                    <a:bodyPr/>
-                    <a:lstStyle/>
-                    <a:p>
-                      <a:pPr indent="0" marL="0">
-                        <a:buNone/>
-                      </a:pPr>
-                      <a:r>
-                        <a:rPr lang="en-US" sz="1000" dirty="0">
-                          <a:solidFill>
-                            <a:srgbClr val="1A1A2E"/>
-                          </a:solidFill>
-                          <a:latin typeface="Calibri" pitchFamily="34" charset="0"/>
-                          <a:ea typeface="Calibri" pitchFamily="34" charset="-122"/>
-                          <a:cs typeface="Calibri" pitchFamily="34" charset="-120"/>
-                        </a:rPr>
-                        <a:t>(not run)</a:t>
-                      </a:r>
-                      <a:endParaRPr lang="en-US" sz="1000" dirty="0">
-                        <a:latin typeface="Calibri" charset="0"/>
-                        <a:ea typeface="Calibri" charset="0"/>
-                        <a:cs typeface="Calibri" charset="0"/>
-                      </a:endParaRPr>
-                    </a:p>
-                  </a:txBody>
-                  <a:tcPr marL="91440" marR="91440" marT="45720" marB="45720">
-                    <a:lnL w="6350" cap="flat" cmpd="sng" algn="ctr">
-                      <a:solidFill>
-                        <a:srgbClr val="CCCCCC"/>
-                      </a:solidFill>
-                      <a:prstDash val="solid"/>
-                      <a:round/>
-                      <a:headEnd type="none" w="med" len="med"/>
-                      <a:tailEnd type="none" w="med" len="med"/>
-                    </a:lnL>
-                    <a:lnR w="6350" cap="flat" cmpd="sng" algn="ctr">
-                      <a:solidFill>
-                        <a:srgbClr val="CCCCCC"/>
-                      </a:solidFill>
-                      <a:prstDash val="solid"/>
-                      <a:round/>
-                      <a:headEnd type="none" w="med" len="med"/>
-                      <a:tailEnd type="none" w="med" len="med"/>
-                    </a:lnR>
-                    <a:lnT w="6350" cap="flat" cmpd="sng" algn="ctr">
-                      <a:solidFill>
-                        <a:srgbClr val="CCCCCC"/>
-                      </a:solidFill>
-                      <a:prstDash val="solid"/>
-                      <a:round/>
-                      <a:headEnd type="none" w="med" len="med"/>
-                      <a:tailEnd type="none" w="med" len="med"/>
-                    </a:lnT>
-                    <a:lnB w="6350" cap="flat" cmpd="sng" algn="ctr">
-                      <a:solidFill>
-                        <a:srgbClr val="CCCCCC"/>
-                      </a:solidFill>
-                      <a:prstDash val="solid"/>
-                      <a:round/>
-                      <a:headEnd type="none" w="med" len="med"/>
-                      <a:tailEnd type="none" w="med" len="med"/>
-                    </a:lnB>
-                  </a:tcPr>
-                </a:tc>
-                <a:tc>
-                  <a:txBody>
-                    <a:bodyPr/>
-                    <a:lstStyle/>
-                    <a:p>
-                      <a:pPr indent="0" marL="0">
-                        <a:buNone/>
-                      </a:pPr>
-                      <a:r>
-                        <a:rPr lang="en-US" sz="1000" dirty="0">
-                          <a:solidFill>
-                            <a:srgbClr val="1A1A2E"/>
-                          </a:solidFill>
-                          <a:latin typeface="Calibri" pitchFamily="34" charset="0"/>
-                          <a:ea typeface="Calibri" pitchFamily="34" charset="-122"/>
-                          <a:cs typeface="Calibri" pitchFamily="34" charset="-120"/>
-                        </a:rPr>
-                        <a:t>Monotonic but nonlinear signal</a:t>
-                      </a:r>
-                      <a:endParaRPr lang="en-US" sz="1000" dirty="0">
-                        <a:latin typeface="Calibri" charset="0"/>
-                        <a:ea typeface="Calibri" charset="0"/>
-                        <a:cs typeface="Calibri" charset="0"/>
-                      </a:endParaRPr>
-                    </a:p>
-                  </a:txBody>
-                  <a:tcPr marL="91440" marR="91440" marT="45720" marB="45720">
-                    <a:lnL w="6350" cap="flat" cmpd="sng" algn="ctr">
-                      <a:solidFill>
-                        <a:srgbClr val="CCCCCC"/>
-                      </a:solidFill>
-                      <a:prstDash val="solid"/>
-                      <a:round/>
-                      <a:headEnd type="none" w="med" len="med"/>
-                      <a:tailEnd type="none" w="med" len="med"/>
-                    </a:lnL>
-                    <a:lnR w="6350" cap="flat" cmpd="sng" algn="ctr">
-                      <a:solidFill>
-                        <a:srgbClr val="CCCCCC"/>
-                      </a:solidFill>
-                      <a:prstDash val="solid"/>
-                      <a:round/>
-                      <a:headEnd type="none" w="med" len="med"/>
-                      <a:tailEnd type="none" w="med" len="med"/>
-                    </a:lnR>
-                    <a:lnT w="6350" cap="flat" cmpd="sng" algn="ctr">
-                      <a:solidFill>
-                        <a:srgbClr val="CCCCCC"/>
-                      </a:solidFill>
-                      <a:prstDash val="solid"/>
-                      <a:round/>
-                      <a:headEnd type="none" w="med" len="med"/>
-                      <a:tailEnd type="none" w="med" len="med"/>
-                    </a:lnT>
-                    <a:lnB w="6350" cap="flat" cmpd="sng" algn="ctr">
-                      <a:solidFill>
-                        <a:srgbClr val="CCCCCC"/>
-                      </a:solidFill>
-                      <a:prstDash val="solid"/>
-                      <a:round/>
-                      <a:headEnd type="none" w="med" len="med"/>
-                      <a:tailEnd type="none" w="med" len="med"/>
-                    </a:lnB>
-                  </a:tcPr>
-                </a:tc>
-              </a:tr>
-              <a:tr h="384048">
-                <a:tc>
-                  <a:txBody>
-                    <a:bodyPr/>
-                    <a:lstStyle/>
-                    <a:p>
-                      <a:pPr indent="0" marL="0">
-                        <a:buNone/>
-                      </a:pPr>
-                      <a:r>
-                        <a:rPr lang="en-US" sz="1000" dirty="0">
-                          <a:solidFill>
-                            <a:srgbClr val="1A1A2E"/>
-                          </a:solidFill>
-                          <a:latin typeface="Calibri" pitchFamily="34" charset="0"/>
-                          <a:ea typeface="Calibri" pitchFamily="34" charset="-122"/>
-                          <a:cs typeface="Calibri" pitchFamily="34" charset="-120"/>
-                        </a:rPr>
                         <a:t>MHDEV 3-region fit</a:t>
                       </a:r>
                       <a:endParaRPr lang="en-US" sz="1000" dirty="0">
@@ -13728,7 +13531,7 @@
                           <a:ea typeface="Calibri" pitchFamily="34" charset="-122"/>
                           <a:cs typeface="Calibri" pitchFamily="34" charset="-120"/>
                         </a:rPr>
-                        <a:t>0.07 / 0.09 / 0.78</a:t>
+                        <a:t>0.05 / 0.08 / 0.79</a:t>
                       </a:r>
                       <a:endParaRPr lang="en-US" sz="1000" dirty="0">
                         <a:latin typeface="Calibri" charset="0"/>
@@ -13796,7 +13599,7 @@
                           <a:ea typeface="Calibri" pitchFamily="34" charset="-122"/>
                           <a:cs typeface="Calibri" pitchFamily="34" charset="-120"/>
                         </a:rPr>
-                        <a:t>~12× better than naive</a:t>
+                        <a:t>~18×/11×/2× vs naive</a:t>
                       </a:r>
                       <a:endParaRPr lang="en-US" sz="1000" dirty="0">
                         <a:latin typeface="Calibri" charset="0"/>
@@ -13937,7 +13740,7 @@
                 <a:ea typeface="Calibri" pitchFamily="34" charset="-122"/>
                 <a:cs typeface="Calibri" pitchFamily="34" charset="-120"/>
               </a:rPr>
-              <a:t>Monotonic but nonlinear — justifies tree ensembles over linear regression.</a:t>
+              <a:t>Relationships are monotonic but clearly nonlinear — motivates tree ensembles.</a:t>
             </a:r>
             <a:endParaRPr lang="en-US" sz="1100" dirty="0"/>
           </a:p>

</xml_diff>